<commit_message>
Revisão Piloto IND-02: correções do portal
- Nomenclatura unificada para "eixo temático" (home, nav, filtro, breadcrumb)
- Hero enxuto (remove parágrafo redundante)
- Legenda dos códigos CAP/IJC/IND + autor/ano nos cards do acervo
- Hotsite: tiles sem subtítulos, links em nova aba (target=_blank)
- História visual: renomeada (era "Narrativa visual"), aviso de proveniência dos dados
- Vídeo: disclaimer de conteúdo gerado por IA
- Mapa mental: autoFit + altura responsiva (não corta ao expandir)
- "Como citar" reordenado para o último item da Leitura
- Base de dados: rótulo claro do repositório aberto
- Assets atualizados: apostila, resumo, fichamento (PDF/PPTX)

Co-Authored-By: Claude Opus 4.8 (1M context) <noreply@anthropic.com>
</commit_message>
<xml_diff>
--- a/public/assets/IND-02/fichamento-dmaic.pptx
+++ b/public/assets/IND-02/fichamento-dmaic.pptx
@@ -3266,9 +3266,52 @@
           </a:p>
         </p:txBody>
       </p:sp>
+      <p:sp>
+        <p:nvSpPr>
+          <p:cNvPr id="6" name="Rectangle 5"/>
+          <p:cNvSpPr/>
+          <p:nvPr/>
+        </p:nvSpPr>
+        <p:spPr>
+          <a:xfrm>
+            <a:off x="411480" y="329184"/>
+            <a:ext cx="2011680" cy="960120"/>
+          </a:xfrm>
+          <a:prstGeom prst="rect">
+            <a:avLst/>
+          </a:prstGeom>
+          <a:solidFill>
+            <a:srgbClr val="FFFFFF"/>
+          </a:solidFill>
+          <a:ln>
+            <a:noFill/>
+          </a:ln>
+        </p:spPr>
+        <p:style>
+          <a:lnRef idx="1">
+            <a:schemeClr val="accent1"/>
+          </a:lnRef>
+          <a:fillRef idx="3">
+            <a:schemeClr val="accent1"/>
+          </a:fillRef>
+          <a:effectRef idx="2">
+            <a:schemeClr val="accent1"/>
+          </a:effectRef>
+          <a:fontRef idx="minor">
+            <a:schemeClr val="lt1"/>
+          </a:fontRef>
+        </p:style>
+        <p:txBody>
+          <a:bodyPr rtlCol="0" anchor="ctr"/>
+          <a:lstStyle/>
+          <a:p>
+            <a:pPr algn="ctr"/>
+          </a:p>
+        </p:txBody>
+      </p:sp>
       <p:pic>
         <p:nvPicPr>
-          <p:cNvPr id="6" name="Picture 5" descr="LogoSusDigital.png"/>
+          <p:cNvPr id="7" name="Picture 6" descr="LogoSusDigital.png"/>
           <p:cNvPicPr>
             <a:picLocks noChangeAspect="1"/>
           </p:cNvPicPr>
@@ -3292,7 +3335,7 @@
       </p:pic>
       <p:sp>
         <p:nvSpPr>
-          <p:cNvPr id="7" name="TextBox 6"/>
+          <p:cNvPr id="8" name="TextBox 7"/>
           <p:cNvSpPr txBox="1"/>
           <p:nvPr/>
         </p:nvSpPr>
@@ -3327,7 +3370,7 @@
       </p:sp>
       <p:sp>
         <p:nvSpPr>
-          <p:cNvPr id="8" name="TextBox 7"/>
+          <p:cNvPr id="9" name="TextBox 8"/>
           <p:cNvSpPr txBox="1"/>
           <p:nvPr/>
         </p:nvSpPr>
@@ -3362,7 +3405,7 @@
       </p:sp>
       <p:sp>
         <p:nvSpPr>
-          <p:cNvPr id="9" name="TextBox 8"/>
+          <p:cNvPr id="10" name="TextBox 9"/>
           <p:cNvSpPr txBox="1"/>
           <p:nvPr/>
         </p:nvSpPr>
@@ -3397,7 +3440,7 @@
       </p:sp>
       <p:sp>
         <p:nvSpPr>
-          <p:cNvPr id="10" name="TextBox 9"/>
+          <p:cNvPr id="11" name="TextBox 10"/>
           <p:cNvSpPr txBox="1"/>
           <p:nvPr/>
         </p:nvSpPr>
@@ -3432,7 +3475,7 @@
       </p:sp>
       <p:sp>
         <p:nvSpPr>
-          <p:cNvPr id="11" name="TextBox 10"/>
+          <p:cNvPr id="12" name="TextBox 11"/>
           <p:cNvSpPr txBox="1"/>
           <p:nvPr/>
         </p:nvSpPr>
@@ -3467,7 +3510,7 @@
       </p:sp>
       <p:sp>
         <p:nvSpPr>
-          <p:cNvPr id="12" name="TextBox 11"/>
+          <p:cNvPr id="13" name="TextBox 12"/>
           <p:cNvSpPr txBox="1"/>
           <p:nvPr/>
         </p:nvSpPr>
@@ -6876,42 +6919,7 @@
       </p:sp>
       <p:sp>
         <p:nvSpPr>
-          <p:cNvPr id="8" name="TextBox 7"/>
-          <p:cNvSpPr txBox="1"/>
-          <p:nvPr/>
-        </p:nvSpPr>
-        <p:spPr>
-          <a:xfrm>
-            <a:off x="548640" y="3657600"/>
-            <a:ext cx="10789920" cy="822960"/>
-          </a:xfrm>
-          <a:prstGeom prst="rect">
-            <a:avLst/>
-          </a:prstGeom>
-          <a:noFill/>
-        </p:spPr>
-        <p:txBody>
-          <a:bodyPr wrap="square" anchor="t">
-            <a:spAutoFit/>
-          </a:bodyPr>
-          <a:lstStyle/>
-          <a:p>
-            <a:pPr algn="l"/>
-            <a:r>
-              <a:rPr sz="1200" b="0" i="0">
-                <a:solidFill>
-                  <a:srgbClr val="D5DFFF"/>
-                </a:solidFill>
-                <a:latin typeface="Rawline"/>
-              </a:rPr>
-              <a:t>Produtos irmãos: apostila didática · resumo · vídeo · podcast · infográfico · base aberta · painel BI</a:t>
-            </a:r>
-          </a:p>
-        </p:txBody>
-      </p:sp>
-      <p:sp>
-        <p:nvSpPr>
-          <p:cNvPr id="9" name="Rectangle 8"/>
+          <p:cNvPr id="8" name="Rectangle 7"/>
           <p:cNvSpPr/>
           <p:nvPr/>
         </p:nvSpPr>
@@ -6954,7 +6962,7 @@
       </p:sp>
       <p:pic>
         <p:nvPicPr>
-          <p:cNvPr id="10" name="Picture 9" descr="regua-institucional.png"/>
+          <p:cNvPr id="9" name="Picture 8" descr="regua-institucional.png"/>
           <p:cNvPicPr>
             <a:picLocks noChangeAspect="1"/>
           </p:cNvPicPr>

</xml_diff>